<commit_message>
docs: Chuan hoa ten Giang vien huong dan ThS. Nguyen Hoang Duy Thien tren toan bo he thong
</commit_message>
<xml_diff>
--- a/thesis/abs/SLIDE_THUYET_TRINH_DO_AN.pptx
+++ b/thesis/abs/SLIDE_THUYET_TRINH_DO_AN.pptx
@@ -5126,7 +5126,11 @@
               </a:defRPr>
             </a:pPr>
             <a:r>
-              <a:t>Số điện thoại: 0329886903     •     Email: truongta150500@sv-onuni.edu.vn</a:t>
+              <a:t>Giảng viên hướng dẫn: ThS. NGUYỄN HOÀNG DUY THIỆN  (Email: thiennhd@tvu.edu.vn)</a:t>
+            </a:r>
+            <a:br/>
+            <a:r>
+              <a:t>Số điện thoại: 0329886903  •  Email: truongta150500@sv-onuni.edu.vn</a:t>
             </a:r>
           </a:p>
           <a:p>

</xml_diff>

<commit_message>
docs: Cap nhat tieu de do an thanh: Xay dung Website ban thuc pham che bien tren nen tang cac phan mem ma nguon mo
</commit_message>
<xml_diff>
--- a/thesis/abs/SLIDE_THUYET_TRINH_DO_AN.pptx
+++ b/thesis/abs/SLIDE_THUYET_TRINH_DO_AN.pptx
@@ -5065,11 +5065,7 @@
               </a:defRPr>
             </a:pPr>
             <a:r>
-              <a:t>XÂY DỰNG WEBSITE BÁN THỰC PHẨM CHẾ BIẾN ĐẶC SẢN BẾN TRE</a:t>
-            </a:r>
-            <a:br/>
-            <a:r>
-              <a:t>TRÊN MÁY CHỦ MÃ NGUỒN MỞ LAMP VÀ WORDPRESS</a:t>
+              <a:t>XÂY DỰNG WEBSITE BÁN THỰC PHẨM CHẾ BIẾN TRÊN NỀN TẢNG CÁC PHẦN MỀM MÃ NGUỒN MỞ</a:t>
             </a:r>
           </a:p>
           <a:p>
@@ -5477,7 +5473,7 @@
               </a:defRPr>
             </a:pPr>
             <a:r>
-              <a:t>Đồ án: Website TMĐT Đặc Sản Bến Tre (Mô hình Bách Hóa Xanh &amp; Sao lưu Xshell, Xftp) | SV: Thạch An Trường</a:t>
+              <a:t>Đồ án: Xây dựng Website bán thực phẩm chế biến trên nền tảng các phần mềm mã nguồn mở | SV: Thạch An Trường</a:t>
             </a:r>
           </a:p>
         </p:txBody>
@@ -6243,7 +6239,7 @@
               </a:defRPr>
             </a:pPr>
             <a:r>
-              <a:t>Đồ án: Website TMĐT Đặc Sản Bến Tre (Mô hình Bách Hóa Xanh &amp; Sao lưu Xshell, Xftp) | SV: Thạch An Trường</a:t>
+              <a:t>Đồ án: Xây dựng Website bán thực phẩm chế biến trên nền tảng các phần mềm mã nguồn mở | SV: Thạch An Trường</a:t>
             </a:r>
           </a:p>
         </p:txBody>
@@ -7009,7 +7005,7 @@
               </a:defRPr>
             </a:pPr>
             <a:r>
-              <a:t>Đồ án: Website TMĐT Đặc Sản Bến Tre (Mô hình Bách Hóa Xanh &amp; Sao lưu Xshell, Xftp) | SV: Thạch An Trường</a:t>
+              <a:t>Đồ án: Xây dựng Website bán thực phẩm chế biến trên nền tảng các phần mềm mã nguồn mở | SV: Thạch An Trường</a:t>
             </a:r>
           </a:p>
         </p:txBody>
@@ -7775,7 +7771,7 @@
               </a:defRPr>
             </a:pPr>
             <a:r>
-              <a:t>Đồ án: Website TMĐT Đặc Sản Bến Tre (Mô hình Bách Hóa Xanh &amp; Sao lưu Xshell, Xftp) | SV: Thạch An Trường</a:t>
+              <a:t>Đồ án: Xây dựng Website bán thực phẩm chế biến trên nền tảng các phần mềm mã nguồn mở | SV: Thạch An Trường</a:t>
             </a:r>
           </a:p>
         </p:txBody>
@@ -8541,7 +8537,7 @@
               </a:defRPr>
             </a:pPr>
             <a:r>
-              <a:t>Đồ án: Website TMĐT Đặc Sản Bến Tre (Mô hình Bách Hóa Xanh &amp; Sao lưu Xshell, Xftp) | SV: Thạch An Trường</a:t>
+              <a:t>Đồ án: Xây dựng Website bán thực phẩm chế biến trên nền tảng các phần mềm mã nguồn mở | SV: Thạch An Trường</a:t>
             </a:r>
           </a:p>
         </p:txBody>
@@ -9307,7 +9303,7 @@
               </a:defRPr>
             </a:pPr>
             <a:r>
-              <a:t>Đồ án: Website TMĐT Đặc Sản Bến Tre (Mô hình Bách Hóa Xanh &amp; Sao lưu Xshell, Xftp) | SV: Thạch An Trường</a:t>
+              <a:t>Đồ án: Xây dựng Website bán thực phẩm chế biến trên nền tảng các phần mềm mã nguồn mở | SV: Thạch An Trường</a:t>
             </a:r>
           </a:p>
         </p:txBody>
@@ -10118,7 +10114,7 @@
               </a:defRPr>
             </a:pPr>
             <a:r>
-              <a:t>Đồ án: Website TMĐT Đặc Sản Bến Tre (Mô hình Bách Hóa Xanh &amp; Sao lưu Xshell, Xftp) | SV: Thạch An Trường</a:t>
+              <a:t>Đồ án: Xây dựng Website bán thực phẩm chế biến trên nền tảng các phần mềm mã nguồn mở | SV: Thạch An Trường</a:t>
             </a:r>
           </a:p>
         </p:txBody>
@@ -10899,7 +10895,7 @@
               </a:defRPr>
             </a:pPr>
             <a:r>
-              <a:t>Đồ án: Website TMĐT Đặc Sản Bến Tre (Mô hình Bách Hóa Xanh &amp; Sao lưu Xshell, Xftp) | SV: Thạch An Trường</a:t>
+              <a:t>Đồ án: Xây dựng Website bán thực phẩm chế biến trên nền tảng các phần mềm mã nguồn mở | SV: Thạch An Trường</a:t>
             </a:r>
           </a:p>
         </p:txBody>
@@ -12178,7 +12174,7 @@
               </a:defRPr>
             </a:pPr>
             <a:r>
-              <a:t>Đồ án: Website TMĐT Đặc Sản Bến Tre (Mô hình Bách Hóa Xanh &amp; Sao lưu Xshell, Xftp) | SV: Thạch An Trường</a:t>
+              <a:t>Đồ án: Xây dựng Website bán thực phẩm chế biến trên nền tảng các phần mềm mã nguồn mở | SV: Thạch An Trường</a:t>
             </a:r>
           </a:p>
         </p:txBody>
@@ -13173,7 +13169,7 @@
               </a:defRPr>
             </a:pPr>
             <a:r>
-              <a:t>Đồ án: Website TMĐT Đặc Sản Bến Tre (Mô hình Bách Hóa Xanh &amp; Sao lưu Xshell, Xftp) | SV: Thạch An Trường</a:t>
+              <a:t>Đồ án: Xây dựng Website bán thực phẩm chế biến trên nền tảng các phần mềm mã nguồn mở | SV: Thạch An Trường</a:t>
             </a:r>
           </a:p>
         </p:txBody>
@@ -13884,7 +13880,7 @@
               </a:defRPr>
             </a:pPr>
             <a:r>
-              <a:t>Đồ án: Website TMĐT Đặc Sản Bến Tre (Mô hình Bách Hóa Xanh &amp; Sao lưu Xshell, Xftp) | SV: Thạch An Trường</a:t>
+              <a:t>Đồ án: Xây dựng Website bán thực phẩm chế biến trên nền tảng các phần mềm mã nguồn mở | SV: Thạch An Trường</a:t>
             </a:r>
           </a:p>
         </p:txBody>
@@ -15753,7 +15749,7 @@
               </a:defRPr>
             </a:pPr>
             <a:r>
-              <a:t>Đồ án: Website TMĐT Đặc Sản Bến Tre (Mô hình Bách Hóa Xanh &amp; Sao lưu Xshell, Xftp) | SV: Thạch An Trường</a:t>
+              <a:t>Đồ án: Xây dựng Website bán thực phẩm chế biến trên nền tảng các phần mềm mã nguồn mở | SV: Thạch An Trường</a:t>
             </a:r>
           </a:p>
         </p:txBody>
@@ -16512,7 +16508,7 @@
               </a:defRPr>
             </a:pPr>
             <a:r>
-              <a:t>Đồ án: Website TMĐT Đặc Sản Bến Tre (Mô hình Bách Hóa Xanh &amp; Sao lưu Xshell, Xftp) | SV: Thạch An Trường</a:t>
+              <a:t>Đồ án: Xây dựng Website bán thực phẩm chế biến trên nền tảng các phần mềm mã nguồn mở | SV: Thạch An Trường</a:t>
             </a:r>
           </a:p>
         </p:txBody>
@@ -17483,7 +17479,7 @@
               </a:defRPr>
             </a:pPr>
             <a:r>
-              <a:t>Đồ án: Website TMĐT Đặc Sản Bến Tre (Mô hình Bách Hóa Xanh &amp; Sao lưu Xshell, Xftp) | SV: Thạch An Trường</a:t>
+              <a:t>Đồ án: Xây dựng Website bán thực phẩm chế biến trên nền tảng các phần mềm mã nguồn mở | SV: Thạch An Trường</a:t>
             </a:r>
           </a:p>
         </p:txBody>
@@ -18224,7 +18220,7 @@
               </a:defRPr>
             </a:pPr>
             <a:r>
-              <a:t>Đồ án: Website TMĐT Đặc Sản Bến Tre (Mô hình Bách Hóa Xanh &amp; Sao lưu Xshell, Xftp) | SV: Thạch An Trường</a:t>
+              <a:t>Đồ án: Xây dựng Website bán thực phẩm chế biến trên nền tảng các phần mềm mã nguồn mở | SV: Thạch An Trường</a:t>
             </a:r>
           </a:p>
         </p:txBody>
@@ -19324,7 +19320,7 @@
               </a:defRPr>
             </a:pPr>
             <a:r>
-              <a:t>Đồ án: Website TMĐT Đặc Sản Bến Tre (Mô hình Bách Hóa Xanh &amp; Sao lưu Xshell, Xftp) | SV: Thạch An Trường</a:t>
+              <a:t>Đồ án: Xây dựng Website bán thực phẩm chế biến trên nền tảng các phần mềm mã nguồn mở | SV: Thạch An Trường</a:t>
             </a:r>
           </a:p>
         </p:txBody>
@@ -20105,7 +20101,7 @@
               </a:defRPr>
             </a:pPr>
             <a:r>
-              <a:t>Đồ án: Website TMĐT Đặc Sản Bến Tre (Mô hình Bách Hóa Xanh &amp; Sao lưu Xshell, Xftp) | SV: Thạch An Trường</a:t>
+              <a:t>Đồ án: Xây dựng Website bán thực phẩm chế biến trên nền tảng các phần mềm mã nguồn mở | SV: Thạch An Trường</a:t>
             </a:r>
           </a:p>
         </p:txBody>
@@ -20871,7 +20867,7 @@
               </a:defRPr>
             </a:pPr>
             <a:r>
-              <a:t>Đồ án: Website TMĐT Đặc Sản Bến Tre (Mô hình Bách Hóa Xanh &amp; Sao lưu Xshell, Xftp) | SV: Thạch An Trường</a:t>
+              <a:t>Đồ án: Xây dựng Website bán thực phẩm chế biến trên nền tảng các phần mềm mã nguồn mở | SV: Thạch An Trường</a:t>
             </a:r>
           </a:p>
         </p:txBody>

</xml_diff>